<commit_message>
Add real hardware photos to executive deck, remove TRL-7 emphasis
Replace abstract graphics with 6 authentic photos sourced from the
June 2026 project report (Sumber Dokumen/[JUNE 2026] GAS LEAK
DETECTION [PERTAMINA]...pdf) - the closest thing to a proposal doc
in the repo, now catalogued as such: sensor housing, Cluster Head
PCB, LoRa signal tester with dBm/SNR readout, rooftop solar
installation, and QC sensor batch photo. Drop "TRL-7" wording
throughout per user request, keeping credibility claims phrased
without the jargon.

Co-Authored-By: Claude Sonnet 5 <noreply@anthropic.com>
Claude-Session: https://claude.ai/code/session_01QtH3dwyfuvM9bs2f6492Rb
</commit_message>
<xml_diff>
--- a/Deliverables/GLD_Executive_Presentation.pptx
+++ b/Deliverables/GLD_Executive_Presentation.pptx
@@ -1862,466 +1862,123 @@
         </p:nvSpPr>
         <p:spPr>
           <a:xfrm>
-            <a:off x="9692640" y="1188720"/>
-            <a:ext cx="1188720" cy="731520"/>
-          </a:xfrm>
-          <a:prstGeom prst="line">
-            <a:avLst/>
-          </a:prstGeom>
-          <a:noFill/>
-          <a:ln w="12700">
-            <a:solidFill>
-              <a:srgbClr val="17607D">
-                <a:alpha val="75000"/>
+            <a:off x="9006840" y="1143000"/>
+            <a:ext cx="2697480" cy="4422038"/>
+          </a:xfrm>
+          <a:prstGeom prst="roundRect">
+            <a:avLst>
+              <a:gd name="adj" fmla="val 2034"/>
+            </a:avLst>
+          </a:prstGeom>
+          <a:solidFill>
+            <a:srgbClr val="FFFFFF"/>
+          </a:solidFill>
+          <a:ln/>
+          <a:effectLst>
+            <a:outerShdw sx="100000" sy="100000" kx="0" ky="0" algn="bl" rotWithShape="0" blurRad="101600" dist="38100" dir="5400000">
+              <a:srgbClr val="000000">
+                <a:alpha val="35000"/>
               </a:srgbClr>
-            </a:solidFill>
-            <a:prstDash val="solid"/>
-          </a:ln>
-        </p:spPr>
-      </p:sp>
-      <p:sp>
-        <p:nvSpPr>
-          <p:cNvPr id="3" name="Shape 1"/>
-          <p:cNvSpPr/>
-          <p:nvPr/>
-        </p:nvSpPr>
-        <p:spPr>
-          <a:xfrm>
-            <a:off x="10881360" y="1920240"/>
-            <a:ext cx="640080" cy="1371600"/>
-          </a:xfrm>
-          <a:prstGeom prst="line">
-            <a:avLst/>
-          </a:prstGeom>
-          <a:noFill/>
-          <a:ln w="12700">
-            <a:solidFill>
-              <a:srgbClr val="17607D">
-                <a:alpha val="75000"/>
-              </a:srgbClr>
-            </a:solidFill>
-            <a:prstDash val="solid"/>
-          </a:ln>
-        </p:spPr>
-      </p:sp>
-      <p:sp>
-        <p:nvSpPr>
-          <p:cNvPr id="4" name="Shape 2"/>
-          <p:cNvSpPr/>
-          <p:nvPr/>
-        </p:nvSpPr>
-        <p:spPr>
-          <a:xfrm flipH="1">
-            <a:off x="10332720" y="3291840"/>
-            <a:ext cx="1188720" cy="822960"/>
-          </a:xfrm>
-          <a:prstGeom prst="line">
-            <a:avLst/>
-          </a:prstGeom>
-          <a:noFill/>
-          <a:ln w="12700">
-            <a:solidFill>
-              <a:srgbClr val="17607D">
-                <a:alpha val="75000"/>
-              </a:srgbClr>
-            </a:solidFill>
-            <a:prstDash val="solid"/>
-          </a:ln>
-        </p:spPr>
-      </p:sp>
-      <p:sp>
-        <p:nvSpPr>
-          <p:cNvPr id="5" name="Shape 3"/>
-          <p:cNvSpPr/>
-          <p:nvPr/>
-        </p:nvSpPr>
-        <p:spPr>
-          <a:xfrm flipH="1" flipV="1">
-            <a:off x="9052560" y="3566160"/>
-            <a:ext cx="1280160" cy="548640"/>
-          </a:xfrm>
-          <a:prstGeom prst="line">
-            <a:avLst/>
-          </a:prstGeom>
-          <a:noFill/>
-          <a:ln w="12700">
-            <a:solidFill>
-              <a:srgbClr val="17607D">
-                <a:alpha val="75000"/>
-              </a:srgbClr>
-            </a:solidFill>
-            <a:prstDash val="solid"/>
-          </a:ln>
-        </p:spPr>
-      </p:sp>
-      <p:sp>
-        <p:nvSpPr>
-          <p:cNvPr id="6" name="Shape 4"/>
-          <p:cNvSpPr/>
-          <p:nvPr/>
-        </p:nvSpPr>
-        <p:spPr>
-          <a:xfrm flipV="1">
-            <a:off x="9052560" y="1188720"/>
-            <a:ext cx="640080" cy="2377440"/>
-          </a:xfrm>
-          <a:prstGeom prst="line">
-            <a:avLst/>
-          </a:prstGeom>
-          <a:noFill/>
-          <a:ln w="12700">
-            <a:solidFill>
-              <a:srgbClr val="17607D">
-                <a:alpha val="75000"/>
-              </a:srgbClr>
-            </a:solidFill>
-            <a:prstDash val="solid"/>
-          </a:ln>
-        </p:spPr>
-      </p:sp>
-      <p:sp>
-        <p:nvSpPr>
-          <p:cNvPr id="7" name="Shape 5"/>
-          <p:cNvSpPr/>
-          <p:nvPr/>
-        </p:nvSpPr>
-        <p:spPr>
-          <a:xfrm flipH="1">
-            <a:off x="9509760" y="4114800"/>
-            <a:ext cx="822960" cy="1005840"/>
-          </a:xfrm>
-          <a:prstGeom prst="line">
-            <a:avLst/>
-          </a:prstGeom>
-          <a:noFill/>
-          <a:ln w="12700">
-            <a:solidFill>
-              <a:srgbClr val="17607D">
-                <a:alpha val="75000"/>
-              </a:srgbClr>
-            </a:solidFill>
-            <a:prstDash val="solid"/>
-          </a:ln>
-        </p:spPr>
-      </p:sp>
-      <p:sp>
-        <p:nvSpPr>
-          <p:cNvPr id="8" name="Shape 6"/>
-          <p:cNvSpPr/>
-          <p:nvPr/>
-        </p:nvSpPr>
-        <p:spPr>
-          <a:xfrm flipH="1" flipV="1">
-            <a:off x="8412480" y="4663440"/>
-            <a:ext cx="1097280" cy="457200"/>
-          </a:xfrm>
-          <a:prstGeom prst="line">
-            <a:avLst/>
-          </a:prstGeom>
-          <a:noFill/>
-          <a:ln w="12700">
-            <a:solidFill>
-              <a:srgbClr val="17607D">
-                <a:alpha val="75000"/>
-              </a:srgbClr>
-            </a:solidFill>
-            <a:prstDash val="solid"/>
-          </a:ln>
-        </p:spPr>
-      </p:sp>
-      <p:sp>
-        <p:nvSpPr>
-          <p:cNvPr id="9" name="Shape 7"/>
-          <p:cNvSpPr/>
-          <p:nvPr/>
-        </p:nvSpPr>
-        <p:spPr>
-          <a:xfrm flipH="1">
-            <a:off x="8412480" y="3566160"/>
-            <a:ext cx="640080" cy="1097280"/>
-          </a:xfrm>
-          <a:prstGeom prst="line">
-            <a:avLst/>
-          </a:prstGeom>
-          <a:noFill/>
-          <a:ln w="12700">
-            <a:solidFill>
-              <a:srgbClr val="17607D">
-                <a:alpha val="75000"/>
-              </a:srgbClr>
-            </a:solidFill>
-            <a:prstDash val="solid"/>
-          </a:ln>
-        </p:spPr>
-      </p:sp>
-      <p:sp>
-        <p:nvSpPr>
-          <p:cNvPr id="10" name="Shape 8"/>
-          <p:cNvSpPr/>
-          <p:nvPr/>
-        </p:nvSpPr>
-        <p:spPr>
-          <a:xfrm>
-            <a:off x="10881360" y="1920240"/>
-            <a:ext cx="274320" cy="3474720"/>
-          </a:xfrm>
-          <a:prstGeom prst="line">
-            <a:avLst/>
-          </a:prstGeom>
-          <a:noFill/>
-          <a:ln w="12700">
-            <a:solidFill>
-              <a:srgbClr val="17607D">
-                <a:alpha val="75000"/>
-              </a:srgbClr>
-            </a:solidFill>
-            <a:prstDash val="solid"/>
-          </a:ln>
-        </p:spPr>
-      </p:sp>
-      <p:sp>
-        <p:nvSpPr>
-          <p:cNvPr id="11" name="Shape 9"/>
-          <p:cNvSpPr/>
-          <p:nvPr/>
-        </p:nvSpPr>
-        <p:spPr>
-          <a:xfrm flipH="1">
-            <a:off x="11155680" y="3291840"/>
-            <a:ext cx="365760" cy="2103120"/>
-          </a:xfrm>
-          <a:prstGeom prst="line">
-            <a:avLst/>
-          </a:prstGeom>
-          <a:noFill/>
-          <a:ln w="12700">
-            <a:solidFill>
-              <a:srgbClr val="17607D">
-                <a:alpha val="75000"/>
-              </a:srgbClr>
-            </a:solidFill>
-            <a:prstDash val="solid"/>
-          </a:ln>
-        </p:spPr>
-      </p:sp>
-      <p:sp>
-        <p:nvSpPr>
-          <p:cNvPr id="12" name="Shape 10"/>
-          <p:cNvSpPr/>
-          <p:nvPr/>
-        </p:nvSpPr>
-        <p:spPr>
-          <a:xfrm>
-            <a:off x="10332720" y="4114800"/>
-            <a:ext cx="822960" cy="1280160"/>
-          </a:xfrm>
-          <a:prstGeom prst="line">
-            <a:avLst/>
-          </a:prstGeom>
-          <a:noFill/>
-          <a:ln w="12700">
-            <a:solidFill>
-              <a:srgbClr val="17607D">
-                <a:alpha val="75000"/>
-              </a:srgbClr>
-            </a:solidFill>
-            <a:prstDash val="solid"/>
-          </a:ln>
-        </p:spPr>
-      </p:sp>
-      <p:sp>
-        <p:nvSpPr>
-          <p:cNvPr id="13" name="Shape 11"/>
-          <p:cNvSpPr/>
-          <p:nvPr/>
-        </p:nvSpPr>
-        <p:spPr>
-          <a:xfrm>
-            <a:off x="9637776" y="1133856"/>
-            <a:ext cx="109728" cy="109728"/>
-          </a:xfrm>
-          <a:prstGeom prst="ellipse">
-            <a:avLst/>
-          </a:prstGeom>
-          <a:solidFill>
-            <a:srgbClr val="F2A93B"/>
-          </a:solidFill>
-          <a:ln/>
-        </p:spPr>
-      </p:sp>
-      <p:sp>
-        <p:nvSpPr>
-          <p:cNvPr id="14" name="Shape 12"/>
-          <p:cNvSpPr/>
-          <p:nvPr/>
-        </p:nvSpPr>
-        <p:spPr>
-          <a:xfrm>
-            <a:off x="10826496" y="1865376"/>
-            <a:ext cx="109728" cy="109728"/>
-          </a:xfrm>
-          <a:prstGeom prst="ellipse">
-            <a:avLst/>
-          </a:prstGeom>
-          <a:solidFill>
-            <a:srgbClr val="F2A93B"/>
-          </a:solidFill>
-          <a:ln/>
-        </p:spPr>
-      </p:sp>
-      <p:sp>
-        <p:nvSpPr>
-          <p:cNvPr id="15" name="Shape 13"/>
-          <p:cNvSpPr/>
-          <p:nvPr/>
-        </p:nvSpPr>
-        <p:spPr>
-          <a:xfrm>
-            <a:off x="11466576" y="3236976"/>
-            <a:ext cx="109728" cy="109728"/>
-          </a:xfrm>
-          <a:prstGeom prst="ellipse">
-            <a:avLst/>
-          </a:prstGeom>
-          <a:solidFill>
-            <a:srgbClr val="F2A93B"/>
-          </a:solidFill>
-          <a:ln/>
-        </p:spPr>
-      </p:sp>
-      <p:sp>
-        <p:nvSpPr>
-          <p:cNvPr id="16" name="Shape 14"/>
-          <p:cNvSpPr/>
-          <p:nvPr/>
-        </p:nvSpPr>
-        <p:spPr>
-          <a:xfrm>
-            <a:off x="10277856" y="4059936"/>
-            <a:ext cx="109728" cy="109728"/>
-          </a:xfrm>
-          <a:prstGeom prst="ellipse">
-            <a:avLst/>
-          </a:prstGeom>
-          <a:solidFill>
-            <a:srgbClr val="F2A93B"/>
-          </a:solidFill>
-          <a:ln/>
-        </p:spPr>
-      </p:sp>
-      <p:sp>
-        <p:nvSpPr>
-          <p:cNvPr id="17" name="Shape 15"/>
-          <p:cNvSpPr/>
-          <p:nvPr/>
-        </p:nvSpPr>
-        <p:spPr>
-          <a:xfrm>
-            <a:off x="8997696" y="3511296"/>
-            <a:ext cx="109728" cy="109728"/>
-          </a:xfrm>
-          <a:prstGeom prst="ellipse">
-            <a:avLst/>
-          </a:prstGeom>
-          <a:solidFill>
-            <a:srgbClr val="F2A93B"/>
-          </a:solidFill>
-          <a:ln/>
-        </p:spPr>
-      </p:sp>
-      <p:sp>
-        <p:nvSpPr>
-          <p:cNvPr id="18" name="Shape 16"/>
-          <p:cNvSpPr/>
-          <p:nvPr/>
-        </p:nvSpPr>
-        <p:spPr>
-          <a:xfrm>
-            <a:off x="9454896" y="5065776"/>
-            <a:ext cx="109728" cy="109728"/>
-          </a:xfrm>
-          <a:prstGeom prst="ellipse">
-            <a:avLst/>
-          </a:prstGeom>
-          <a:solidFill>
-            <a:srgbClr val="F2A93B"/>
-          </a:solidFill>
-          <a:ln/>
-        </p:spPr>
-      </p:sp>
-      <p:sp>
-        <p:nvSpPr>
-          <p:cNvPr id="19" name="Shape 17"/>
-          <p:cNvSpPr/>
-          <p:nvPr/>
-        </p:nvSpPr>
-        <p:spPr>
-          <a:xfrm>
-            <a:off x="11100816" y="5340096"/>
-            <a:ext cx="109728" cy="109728"/>
-          </a:xfrm>
-          <a:prstGeom prst="ellipse">
-            <a:avLst/>
-          </a:prstGeom>
-          <a:solidFill>
-            <a:srgbClr val="F2A93B"/>
-          </a:solidFill>
-          <a:ln/>
-        </p:spPr>
-      </p:sp>
-      <p:sp>
-        <p:nvSpPr>
-          <p:cNvPr id="20" name="Shape 18"/>
-          <p:cNvSpPr/>
-          <p:nvPr/>
-        </p:nvSpPr>
-        <p:spPr>
-          <a:xfrm>
-            <a:off x="8357616" y="4608576"/>
-            <a:ext cx="109728" cy="109728"/>
-          </a:xfrm>
-          <a:prstGeom prst="ellipse">
-            <a:avLst/>
-          </a:prstGeom>
-          <a:solidFill>
-            <a:srgbClr val="F2A93B"/>
-          </a:solidFill>
-          <a:ln/>
-        </p:spPr>
-      </p:sp>
-      <p:sp>
-        <p:nvSpPr>
-          <p:cNvPr id="21" name="Text 19"/>
-          <p:cNvSpPr/>
-          <p:nvPr/>
-        </p:nvSpPr>
-        <p:spPr>
-          <a:xfrm>
-            <a:off x="822960" y="1965960"/>
-            <a:ext cx="8686800" cy="457200"/>
-          </a:xfrm>
-          <a:prstGeom prst="rect">
-            <a:avLst/>
-          </a:prstGeom>
-          <a:noFill/>
-          <a:ln/>
-        </p:spPr>
-        <p:txBody>
-          <a:bodyPr wrap="square" lIns="0" tIns="0" rIns="0" bIns="0" rtlCol="0" anchor="ctr"/>
-          <a:lstStyle/>
-          <a:p>
-            <a:pPr indent="0" marL="0">
-              <a:buNone/>
-            </a:pPr>
-            <a:r>
-              <a:rPr lang="en-US" sz="1500" b="1" spc="300" kern="0" dirty="0">
-                <a:solidFill>
-                  <a:srgbClr val="F2A93B"/>
+            </a:outerShdw>
+          </a:effectLst>
+        </p:spPr>
+      </p:sp>
+      <p:pic>
+        <p:nvPicPr>
+          <p:cNvPr id="3" name="Image 0" descr="/tmp/claude-0/-home-user-GLD-V2-Report-2026/8b852038-2eb2-55a5-9182-130dcc240a6c/scratchpad/gld_pitch/photos/hero_sensor.jpg">    </p:cNvPr>
+          <p:cNvPicPr>
+            <a:picLocks noChangeAspect="1"/>
+          </p:cNvPicPr>
+          <p:nvPr/>
+        </p:nvPicPr>
+        <p:blipFill>
+          <a:blip r:embed="rId1"/>
+          <a:stretch>
+            <a:fillRect/>
+          </a:stretch>
+        </p:blipFill>
+        <p:spPr>
+          <a:xfrm>
+            <a:off x="9057132" y="1193292"/>
+            <a:ext cx="2596896" cy="4321454"/>
+          </a:xfrm>
+          <a:prstGeom prst="rect">
+            <a:avLst/>
+          </a:prstGeom>
+        </p:spPr>
+      </p:pic>
+      <p:sp>
+        <p:nvSpPr>
+          <p:cNvPr id="4" name="Text 1"/>
+          <p:cNvSpPr/>
+          <p:nvPr/>
+        </p:nvSpPr>
+        <p:spPr>
+          <a:xfrm>
+            <a:off x="9006840" y="5614416"/>
+            <a:ext cx="2697480" cy="320040"/>
+          </a:xfrm>
+          <a:prstGeom prst="rect">
+            <a:avLst/>
+          </a:prstGeom>
+          <a:noFill/>
+          <a:ln/>
+        </p:spPr>
+        <p:txBody>
+          <a:bodyPr wrap="square" lIns="0" tIns="0" rIns="0" bIns="0" rtlCol="0" anchor="ctr"/>
+          <a:lstStyle/>
+          <a:p>
+            <a:pPr algn="ctr" indent="0" marL="0">
+              <a:buNone/>
+            </a:pPr>
+            <a:r>
+              <a:rPr lang="en-US" sz="950" i="1" dirty="0">
+                <a:solidFill>
+                  <a:srgbClr val="B9D3E0"/>
                 </a:solidFill>
                 <a:latin typeface="Calibri" pitchFamily="34" charset="0"/>
                 <a:ea typeface="Calibri" pitchFamily="34" charset="-122"/>
                 <a:cs typeface="Calibri" pitchFamily="34" charset="-120"/>
               </a:rPr>
+              <a:t>Unit GLD aktual — bukan render</a:t>
+            </a:r>
+            <a:endParaRPr lang="en-US" sz="950" dirty="0"/>
+          </a:p>
+        </p:txBody>
+      </p:sp>
+      <p:sp>
+        <p:nvSpPr>
+          <p:cNvPr id="5" name="Text 2"/>
+          <p:cNvSpPr/>
+          <p:nvPr/>
+        </p:nvSpPr>
+        <p:spPr>
+          <a:xfrm>
+            <a:off x="822960" y="1965960"/>
+            <a:ext cx="8686800" cy="457200"/>
+          </a:xfrm>
+          <a:prstGeom prst="rect">
+            <a:avLst/>
+          </a:prstGeom>
+          <a:noFill/>
+          <a:ln/>
+        </p:spPr>
+        <p:txBody>
+          <a:bodyPr wrap="square" lIns="0" tIns="0" rIns="0" bIns="0" rtlCol="0" anchor="ctr"/>
+          <a:lstStyle/>
+          <a:p>
+            <a:pPr indent="0" marL="0">
+              <a:buNone/>
+            </a:pPr>
+            <a:r>
+              <a:rPr lang="en-US" sz="1500" b="1" spc="300" kern="0" dirty="0">
+                <a:solidFill>
+                  <a:srgbClr val="F2A93B"/>
+                </a:solidFill>
+                <a:latin typeface="Calibri" pitchFamily="34" charset="0"/>
+                <a:ea typeface="Calibri" pitchFamily="34" charset="-122"/>
+                <a:cs typeface="Calibri" pitchFamily="34" charset="-120"/>
+              </a:rPr>
               <a:t>GAS LEAK DETECTION</a:t>
             </a:r>
             <a:endParaRPr lang="en-US" sz="1500" dirty="0"/>
@@ -2330,7 +1987,7 @@
       </p:sp>
       <p:sp>
         <p:nvSpPr>
-          <p:cNvPr id="22" name="Text 20"/>
+          <p:cNvPr id="6" name="Text 3"/>
           <p:cNvSpPr/>
           <p:nvPr/>
         </p:nvSpPr>
@@ -2369,7 +2026,7 @@
       </p:sp>
       <p:sp>
         <p:nvSpPr>
-          <p:cNvPr id="23" name="Text 21"/>
+          <p:cNvPr id="7" name="Text 4"/>
           <p:cNvSpPr/>
           <p:nvPr/>
         </p:nvSpPr>
@@ -2431,7 +2088,7 @@
       </p:sp>
       <p:sp>
         <p:nvSpPr>
-          <p:cNvPr id="24" name="Text 22"/>
+          <p:cNvPr id="8" name="Text 5"/>
           <p:cNvSpPr/>
           <p:nvPr/>
         </p:nvSpPr>
@@ -4484,7 +4141,7 @@
                 <a:ea typeface="Calibri" pitchFamily="34" charset="-122"/>
                 <a:cs typeface="Calibri" pitchFamily="34" charset="-120"/>
               </a:rPr>
-              <a:t>TRL-7, teruji multi-lokasi, didukung mitra manufaktur untuk volume besar.</a:t>
+              <a:t>Teruji di lebih dari satu lokasi kilang, didukung mitra manufaktur untuk volume besar.</a:t>
             </a:r>
             <a:endParaRPr lang="en-US" sz="1250" dirty="0"/>
           </a:p>
@@ -4918,7 +4575,7 @@
                 <a:ea typeface="Calibri" pitchFamily="34" charset="-122"/>
                 <a:cs typeface="Calibri" pitchFamily="34" charset="-120"/>
               </a:rPr>
-              <a:t>Gas Leak Detection System — TRL-7  ·  contact@[isi kontak tim]</a:t>
+              <a:t>Gas Leak Detection System  ·  contact@[isi kontak tim]</a:t>
             </a:r>
             <a:endParaRPr lang="en-US" sz="1200" dirty="0"/>
           </a:p>
@@ -6693,14 +6350,67 @@
       </p:sp>
       <p:sp>
         <p:nvSpPr>
-          <p:cNvPr id="31" name="Text 25"/>
-          <p:cNvSpPr/>
-          <p:nvPr/>
-        </p:nvSpPr>
-        <p:spPr>
-          <a:xfrm>
-            <a:off x="640080" y="5989320"/>
-            <a:ext cx="10515600" cy="365760"/>
+          <p:cNvPr id="31" name="Shape 25"/>
+          <p:cNvSpPr/>
+          <p:nvPr/>
+        </p:nvSpPr>
+        <p:spPr>
+          <a:xfrm>
+            <a:off x="640080" y="5806440"/>
+            <a:ext cx="869594" cy="777240"/>
+          </a:xfrm>
+          <a:prstGeom prst="roundRect">
+            <a:avLst>
+              <a:gd name="adj" fmla="val 7059"/>
+            </a:avLst>
+          </a:prstGeom>
+          <a:solidFill>
+            <a:srgbClr val="081F38"/>
+          </a:solidFill>
+          <a:ln/>
+          <a:effectLst>
+            <a:outerShdw sx="100000" sy="100000" kx="0" ky="0" algn="bl" rotWithShape="0" blurRad="101600" dist="38100" dir="5400000">
+              <a:srgbClr val="000000">
+                <a:alpha val="35000"/>
+              </a:srgbClr>
+            </a:outerShdw>
+          </a:effectLst>
+        </p:spPr>
+      </p:sp>
+      <p:pic>
+        <p:nvPicPr>
+          <p:cNvPr id="32" name="Image 4" descr="/tmp/claude-0/-home-user-GLD-V2-Report-2026/8b852038-2eb2-55a5-9182-130dcc240a6c/scratchpad/gld_pitch/photos/pcb_hand.jpg">    </p:cNvPr>
+          <p:cNvPicPr>
+            <a:picLocks noChangeAspect="1"/>
+          </p:cNvPicPr>
+          <p:nvPr/>
+        </p:nvPicPr>
+        <p:blipFill>
+          <a:blip r:embed="rId5"/>
+          <a:stretch>
+            <a:fillRect/>
+          </a:stretch>
+        </p:blipFill>
+        <p:spPr>
+          <a:xfrm>
+            <a:off x="690372" y="5856732"/>
+            <a:ext cx="769010" cy="676656"/>
+          </a:xfrm>
+          <a:prstGeom prst="rect">
+            <a:avLst/>
+          </a:prstGeom>
+        </p:spPr>
+      </p:pic>
+      <p:sp>
+        <p:nvSpPr>
+          <p:cNvPr id="33" name="Text 26"/>
+          <p:cNvSpPr/>
+          <p:nvPr/>
+        </p:nvSpPr>
+        <p:spPr>
+          <a:xfrm>
+            <a:off x="1691640" y="5806440"/>
+            <a:ext cx="9418320" cy="777240"/>
           </a:xfrm>
           <a:prstGeom prst="rect">
             <a:avLst/>
@@ -6713,6 +6423,9 @@
           <a:lstStyle/>
           <a:p>
             <a:pPr indent="0" marL="0">
+              <a:lnSpc>
+                <a:spcPct val="115000"/>
+              </a:lnSpc>
               <a:buNone/>
             </a:pPr>
             <a:r>
@@ -6724,7 +6437,7 @@
                 <a:ea typeface="Calibri" pitchFamily="34" charset="-122"/>
                 <a:cs typeface="Calibri" pitchFamily="34" charset="-120"/>
               </a:rPr>
-              <a:t>Level kematangan TRL-7 — teknologi teruji di kilang, bukan lagi prototipe laboratorium.</a:t>
+              <a:t>Prototipe hardware nyata — PCB Cluster Head hasil rekayasa tim, bukan render atau mockup.</a:t>
             </a:r>
             <a:endParaRPr lang="en-US" sz="1250" dirty="0"/>
           </a:p>
@@ -11320,7 +11033,7 @@
         <p:spPr>
           <a:xfrm>
             <a:off x="1353312" y="2926080"/>
-            <a:ext cx="4251960" cy="868680"/>
+            <a:ext cx="4251960" cy="822960"/>
           </a:xfrm>
           <a:prstGeom prst="rect">
             <a:avLst/>
@@ -11369,7 +11082,7 @@
         </p:blipFill>
         <p:spPr>
           <a:xfrm>
-            <a:off x="960120" y="3913632"/>
+            <a:off x="960120" y="3867912"/>
             <a:ext cx="256032" cy="256032"/>
           </a:xfrm>
           <a:prstGeom prst="rect">
@@ -11385,8 +11098,8 @@
         </p:nvSpPr>
         <p:spPr>
           <a:xfrm>
-            <a:off x="1353312" y="3886200"/>
-            <a:ext cx="4251960" cy="868680"/>
+            <a:off x="1353312" y="3840480"/>
+            <a:ext cx="4251960" cy="822960"/>
           </a:xfrm>
           <a:prstGeom prst="rect">
             <a:avLst/>
@@ -11413,15 +11126,44 @@
                 <a:ea typeface="Calibri" pitchFamily="34" charset="-122"/>
                 <a:cs typeface="Calibri" pitchFamily="34" charset="-120"/>
               </a:rPr>
-              <a:t>Model deteksi LPG 8-sensor akurasi ≥92% pada dataset lapangan</a:t>
+              <a:t>Alarm push otomatis teruji: GLD disemprot gas → server menerima alarm tanpa menunggu polling</a:t>
             </a:r>
             <a:endParaRPr lang="en-US" sz="1250" dirty="0"/>
           </a:p>
         </p:txBody>
+      </p:sp>
+      <p:sp>
+        <p:nvSpPr>
+          <p:cNvPr id="13" name="Shape 8"/>
+          <p:cNvSpPr/>
+          <p:nvPr/>
+        </p:nvSpPr>
+        <p:spPr>
+          <a:xfrm>
+            <a:off x="960120" y="4846320"/>
+            <a:ext cx="580644" cy="914400"/>
+          </a:xfrm>
+          <a:prstGeom prst="roundRect">
+            <a:avLst>
+              <a:gd name="adj" fmla="val 9449"/>
+            </a:avLst>
+          </a:prstGeom>
+          <a:solidFill>
+            <a:srgbClr val="0B2E4F"/>
+          </a:solidFill>
+          <a:ln/>
+          <a:effectLst>
+            <a:outerShdw sx="100000" sy="100000" kx="0" ky="0" algn="bl" rotWithShape="0" blurRad="101600" dist="38100" dir="5400000">
+              <a:srgbClr val="000000">
+                <a:alpha val="35000"/>
+              </a:srgbClr>
+            </a:outerShdw>
+          </a:effectLst>
+        </p:spPr>
       </p:sp>
       <p:pic>
         <p:nvPicPr>
-          <p:cNvPr id="13" name="Image 3" descr="/tmp/claude-0/-home-user-GLD-V2-Report-2026/8b852038-2eb2-55a5-9182-130dcc240a6c/scratchpad/gld_pitch/icons_out/checkW.png">    </p:cNvPr>
+          <p:cNvPr id="14" name="Image 3" descr="/tmp/claude-0/-home-user-GLD-V2-Report-2026/8b852038-2eb2-55a5-9182-130dcc240a6c/scratchpad/gld_pitch/photos/lora_tester.jpg">    </p:cNvPr>
           <p:cNvPicPr>
             <a:picLocks noChangeAspect="1"/>
           </p:cNvPicPr>
@@ -11435,8 +11177,8 @@
         </p:blipFill>
         <p:spPr>
           <a:xfrm>
-            <a:off x="960120" y="4873752"/>
-            <a:ext cx="256032" cy="256032"/>
+            <a:off x="1010412" y="4896612"/>
+            <a:ext cx="480060" cy="813816"/>
           </a:xfrm>
           <a:prstGeom prst="rect">
             <a:avLst/>
@@ -11445,14 +11187,14 @@
       </p:pic>
       <p:sp>
         <p:nvSpPr>
-          <p:cNvPr id="14" name="Text 8"/>
-          <p:cNvSpPr/>
-          <p:nvPr/>
-        </p:nvSpPr>
-        <p:spPr>
-          <a:xfrm>
-            <a:off x="1353312" y="4846320"/>
-            <a:ext cx="4251960" cy="868680"/>
+          <p:cNvPr id="15" name="Text 9"/>
+          <p:cNvSpPr/>
+          <p:nvPr/>
+        </p:nvSpPr>
+        <p:spPr>
+          <a:xfrm>
+            <a:off x="1769364" y="4846320"/>
+            <a:ext cx="3808476" cy="914400"/>
           </a:xfrm>
           <a:prstGeom prst="rect">
             <a:avLst/>
@@ -11466,12 +11208,12 @@
           <a:p>
             <a:pPr indent="0" marL="0">
               <a:lnSpc>
-                <a:spcPct val="120000"/>
+                <a:spcPct val="115000"/>
               </a:lnSpc>
               <a:buNone/>
             </a:pPr>
             <a:r>
-              <a:rPr lang="en-US" sz="1250" dirty="0">
+              <a:rPr lang="en-US" sz="1050" i="1" dirty="0">
                 <a:solidFill>
                   <a:srgbClr val="B9D3E0"/>
                 </a:solidFill>
@@ -11479,15 +11221,15 @@
                 <a:ea typeface="Calibri" pitchFamily="34" charset="-122"/>
                 <a:cs typeface="Calibri" pitchFamily="34" charset="-120"/>
               </a:rPr>
-              <a:t>Alarm push otomatis teruji: GLD disemprot gas → server menerima alarm tanpa menunggu polling</a:t>
-            </a:r>
-            <a:endParaRPr lang="en-US" sz="1250" dirty="0"/>
-          </a:p>
-        </p:txBody>
-      </p:sp>
-      <p:sp>
-        <p:nvSpPr>
-          <p:cNvPr id="15" name="Shape 9"/>
+              <a:t>Sinyal mesh diukur langsung di lapangan (dBm/SNR) — model LPG 8-sensor akurasi ≥92%.</a:t>
+            </a:r>
+            <a:endParaRPr lang="en-US" sz="1050" dirty="0"/>
+          </a:p>
+        </p:txBody>
+      </p:sp>
+      <p:sp>
+        <p:nvSpPr>
+          <p:cNvPr id="16" name="Shape 10"/>
           <p:cNvSpPr/>
           <p:nvPr/>
         </p:nvSpPr>
@@ -11514,7 +11256,7 @@
       </p:sp>
       <p:sp>
         <p:nvSpPr>
-          <p:cNvPr id="16" name="Shape 10"/>
+          <p:cNvPr id="17" name="Shape 11"/>
           <p:cNvSpPr/>
           <p:nvPr/>
         </p:nvSpPr>
@@ -11534,7 +11276,7 @@
       </p:sp>
       <p:pic>
         <p:nvPicPr>
-          <p:cNvPr id="17" name="Image 4" descr="/tmp/claude-0/-home-user-GLD-V2-Report-2026/8b852038-2eb2-55a5-9182-130dcc240a6c/scratchpad/gld_pitch/icons_out/loc.png">    </p:cNvPr>
+          <p:cNvPr id="18" name="Image 4" descr="/tmp/claude-0/-home-user-GLD-V2-Report-2026/8b852038-2eb2-55a5-9182-130dcc240a6c/scratchpad/gld_pitch/icons_out/loc.png">    </p:cNvPr>
           <p:cNvPicPr>
             <a:picLocks noChangeAspect="1"/>
           </p:cNvPicPr>
@@ -11558,7 +11300,7 @@
       </p:pic>
       <p:sp>
         <p:nvSpPr>
-          <p:cNvPr id="18" name="Text 11"/>
+          <p:cNvPr id="19" name="Text 12"/>
           <p:cNvSpPr/>
           <p:nvPr/>
         </p:nvSpPr>
@@ -11597,7 +11339,7 @@
       </p:sp>
       <p:sp>
         <p:nvSpPr>
-          <p:cNvPr id="19" name="Shape 12"/>
+          <p:cNvPr id="20" name="Shape 13"/>
           <p:cNvSpPr/>
           <p:nvPr/>
         </p:nvSpPr>
@@ -11619,7 +11361,7 @@
       </p:sp>
       <p:sp>
         <p:nvSpPr>
-          <p:cNvPr id="20" name="Text 13"/>
+          <p:cNvPr id="21" name="Text 14"/>
           <p:cNvSpPr/>
           <p:nvPr/>
         </p:nvSpPr>
@@ -11658,7 +11400,7 @@
       </p:sp>
       <p:pic>
         <p:nvPicPr>
-          <p:cNvPr id="21" name="Image 5" descr="/tmp/claude-0/-home-user-GLD-V2-Report-2026/8b852038-2eb2-55a5-9182-130dcc240a6c/scratchpad/gld_pitch/icons_out/checkW.png">    </p:cNvPr>
+          <p:cNvPr id="22" name="Image 5" descr="/tmp/claude-0/-home-user-GLD-V2-Report-2026/8b852038-2eb2-55a5-9182-130dcc240a6c/scratchpad/gld_pitch/icons_out/checkW.png">    </p:cNvPr>
           <p:cNvPicPr>
             <a:picLocks noChangeAspect="1"/>
           </p:cNvPicPr>
@@ -11682,14 +11424,14 @@
       </p:pic>
       <p:sp>
         <p:nvSpPr>
-          <p:cNvPr id="22" name="Text 14"/>
+          <p:cNvPr id="23" name="Text 15"/>
           <p:cNvSpPr/>
           <p:nvPr/>
         </p:nvSpPr>
         <p:spPr>
           <a:xfrm>
             <a:off x="6976872" y="2926080"/>
-            <a:ext cx="4251960" cy="868680"/>
+            <a:ext cx="4251960" cy="822960"/>
           </a:xfrm>
           <a:prstGeom prst="rect">
             <a:avLst/>
@@ -11724,7 +11466,7 @@
       </p:sp>
       <p:pic>
         <p:nvPicPr>
-          <p:cNvPr id="23" name="Image 6" descr="/tmp/claude-0/-home-user-GLD-V2-Report-2026/8b852038-2eb2-55a5-9182-130dcc240a6c/scratchpad/gld_pitch/icons_out/checkW.png">    </p:cNvPr>
+          <p:cNvPr id="24" name="Image 6" descr="/tmp/claude-0/-home-user-GLD-V2-Report-2026/8b852038-2eb2-55a5-9182-130dcc240a6c/scratchpad/gld_pitch/icons_out/checkW.png">    </p:cNvPr>
           <p:cNvPicPr>
             <a:picLocks noChangeAspect="1"/>
           </p:cNvPicPr>
@@ -11738,7 +11480,7 @@
         </p:blipFill>
         <p:spPr>
           <a:xfrm>
-            <a:off x="6583680" y="3913632"/>
+            <a:off x="6583680" y="3867912"/>
             <a:ext cx="256032" cy="256032"/>
           </a:xfrm>
           <a:prstGeom prst="rect">
@@ -11748,14 +11490,14 @@
       </p:pic>
       <p:sp>
         <p:nvSpPr>
-          <p:cNvPr id="24" name="Text 15"/>
-          <p:cNvSpPr/>
-          <p:nvPr/>
-        </p:nvSpPr>
-        <p:spPr>
-          <a:xfrm>
-            <a:off x="6976872" y="3886200"/>
-            <a:ext cx="4251960" cy="868680"/>
+          <p:cNvPr id="25" name="Text 16"/>
+          <p:cNvSpPr/>
+          <p:nvPr/>
+        </p:nvSpPr>
+        <p:spPr>
+          <a:xfrm>
+            <a:off x="6976872" y="3840480"/>
+            <a:ext cx="4251960" cy="822960"/>
           </a:xfrm>
           <a:prstGeom prst="rect">
             <a:avLst/>
@@ -11788,9 +11530,38 @@
           </a:p>
         </p:txBody>
       </p:sp>
+      <p:sp>
+        <p:nvSpPr>
+          <p:cNvPr id="26" name="Shape 17"/>
+          <p:cNvSpPr/>
+          <p:nvPr/>
+        </p:nvSpPr>
+        <p:spPr>
+          <a:xfrm>
+            <a:off x="6583680" y="4846320"/>
+            <a:ext cx="685800" cy="914400"/>
+          </a:xfrm>
+          <a:prstGeom prst="roundRect">
+            <a:avLst>
+              <a:gd name="adj" fmla="val 8000"/>
+            </a:avLst>
+          </a:prstGeom>
+          <a:solidFill>
+            <a:srgbClr val="0B2E4F"/>
+          </a:solidFill>
+          <a:ln/>
+          <a:effectLst>
+            <a:outerShdw sx="100000" sy="100000" kx="0" ky="0" algn="bl" rotWithShape="0" blurRad="101600" dist="38100" dir="5400000">
+              <a:srgbClr val="000000">
+                <a:alpha val="35000"/>
+              </a:srgbClr>
+            </a:outerShdw>
+          </a:effectLst>
+        </p:spPr>
+      </p:sp>
       <p:pic>
         <p:nvPicPr>
-          <p:cNvPr id="25" name="Image 7" descr="/tmp/claude-0/-home-user-GLD-V2-Report-2026/8b852038-2eb2-55a5-9182-130dcc240a6c/scratchpad/gld_pitch/icons_out/checkW.png">    </p:cNvPr>
+          <p:cNvPr id="27" name="Image 7" descr="/tmp/claude-0/-home-user-GLD-V2-Report-2026/8b852038-2eb2-55a5-9182-130dcc240a6c/scratchpad/gld_pitch/photos/rooftop_solar.jpg">    </p:cNvPr>
           <p:cNvPicPr>
             <a:picLocks noChangeAspect="1"/>
           </p:cNvPicPr>
@@ -11804,8 +11575,8 @@
         </p:blipFill>
         <p:spPr>
           <a:xfrm>
-            <a:off x="6583680" y="4873752"/>
-            <a:ext cx="256032" cy="256032"/>
+            <a:off x="6633972" y="4896612"/>
+            <a:ext cx="585216" cy="813816"/>
           </a:xfrm>
           <a:prstGeom prst="rect">
             <a:avLst/>
@@ -11814,14 +11585,14 @@
       </p:pic>
       <p:sp>
         <p:nvSpPr>
-          <p:cNvPr id="26" name="Text 16"/>
-          <p:cNvSpPr/>
-          <p:nvPr/>
-        </p:nvSpPr>
-        <p:spPr>
-          <a:xfrm>
-            <a:off x="6976872" y="4846320"/>
-            <a:ext cx="4251960" cy="868680"/>
+          <p:cNvPr id="28" name="Text 18"/>
+          <p:cNvSpPr/>
+          <p:nvPr/>
+        </p:nvSpPr>
+        <p:spPr>
+          <a:xfrm>
+            <a:off x="7498080" y="4846320"/>
+            <a:ext cx="3703320" cy="914400"/>
           </a:xfrm>
           <a:prstGeom prst="rect">
             <a:avLst/>
@@ -11835,12 +11606,12 @@
           <a:p>
             <a:pPr indent="0" marL="0">
               <a:lnSpc>
-                <a:spcPct val="120000"/>
+                <a:spcPct val="115000"/>
               </a:lnSpc>
               <a:buNone/>
             </a:pPr>
             <a:r>
-              <a:rPr lang="en-US" sz="1250" dirty="0">
+              <a:rPr lang="en-US" sz="1050" i="1" dirty="0">
                 <a:solidFill>
                   <a:srgbClr val="B9D3E0"/>
                 </a:solidFill>
@@ -11848,15 +11619,15 @@
                 <a:ea typeface="Calibri" pitchFamily="34" charset="-122"/>
                 <a:cs typeface="Calibri" pitchFamily="34" charset="-120"/>
               </a:rPr>
-              <a:t>Memperkuat rekam jejak sistem di lebih dari satu lokasi kilang nyata</a:t>
-            </a:r>
-            <a:endParaRPr lang="en-US" sz="1250" dirty="0"/>
-          </a:p>
-        </p:txBody>
-      </p:sp>
-      <p:sp>
-        <p:nvSpPr>
-          <p:cNvPr id="27" name="Text 17"/>
+              <a:t>Instalasi solar panel + Cluster Head di lokasi RU VII — bukti lintas lokasi, bukan cuma simulasi lab.</a:t>
+            </a:r>
+            <a:endParaRPr lang="en-US" sz="1050" dirty="0"/>
+          </a:p>
+        </p:txBody>
+      </p:sp>
+      <p:sp>
+        <p:nvSpPr>
+          <p:cNvPr id="29" name="Text 19"/>
           <p:cNvSpPr/>
           <p:nvPr/>
         </p:nvSpPr>
@@ -11895,7 +11666,7 @@
       </p:sp>
       <p:sp>
         <p:nvSpPr>
-          <p:cNvPr id="28" name="Text 18"/>
+          <p:cNvPr id="30" name="Text 20"/>
           <p:cNvSpPr/>
           <p:nvPr/>
         </p:nvSpPr>
@@ -12039,7 +11810,7 @@
                 <a:ea typeface="Calibri" pitchFamily="34" charset="-122"/>
                 <a:cs typeface="Calibri" pitchFamily="34" charset="-120"/>
               </a:rPr>
-              <a:t>Dirancang &amp; divalidasi TRL-7 oleh LAPI Ganesha Utama bersama Lab IoT dan Lab Fisika ITB — dan didukung mitra manufaktur untuk produksi volume besar.</a:t>
+              <a:t>Direkayasa &amp; diuji langsung oleh LAPI Ganesha Utama bersama Lab IoT dan Lab Fisika ITB — dan didukung mitra manufaktur untuk produksi volume besar.</a:t>
             </a:r>
             <a:endParaRPr lang="en-US" sz="1400" dirty="0"/>
           </a:p>
@@ -12075,21 +11846,30 @@
         </p:nvSpPr>
         <p:spPr>
           <a:xfrm>
-            <a:off x="1005840" y="2514600"/>
-            <a:ext cx="1280160" cy="1280160"/>
-          </a:xfrm>
-          <a:prstGeom prst="ellipse">
-            <a:avLst/>
+            <a:off x="868680" y="2286000"/>
+            <a:ext cx="1201522" cy="1828800"/>
+          </a:xfrm>
+          <a:prstGeom prst="roundRect">
+            <a:avLst>
+              <a:gd name="adj" fmla="val 4566"/>
+            </a:avLst>
           </a:prstGeom>
           <a:solidFill>
-            <a:srgbClr val="17607D"/>
+            <a:srgbClr val="081F38"/>
           </a:solidFill>
           <a:ln/>
+          <a:effectLst>
+            <a:outerShdw sx="100000" sy="100000" kx="0" ky="0" algn="bl" rotWithShape="0" blurRad="101600" dist="38100" dir="5400000">
+              <a:srgbClr val="000000">
+                <a:alpha val="35000"/>
+              </a:srgbClr>
+            </a:outerShdw>
+          </a:effectLst>
         </p:spPr>
       </p:sp>
       <p:pic>
         <p:nvPicPr>
-          <p:cNvPr id="6" name="Image 0" descr="/tmp/claude-0/-home-user-GLD-V2-Report-2026/8b852038-2eb2-55a5-9182-130dcc240a6c/scratchpad/gld_pitch/icons_out/handshake.png">    </p:cNvPr>
+          <p:cNvPr id="6" name="Image 0" descr="/tmp/claude-0/-home-user-GLD-V2-Report-2026/8b852038-2eb2-55a5-9182-130dcc240a6c/scratchpad/gld_pitch/photos/qc_sensors.jpg">    </p:cNvPr>
           <p:cNvPicPr>
             <a:picLocks noChangeAspect="1"/>
           </p:cNvPicPr>
@@ -12103,8 +11883,8 @@
         </p:blipFill>
         <p:spPr>
           <a:xfrm>
-            <a:off x="1298448" y="2807208"/>
-            <a:ext cx="694944" cy="694944"/>
+            <a:off x="918972" y="2336292"/>
+            <a:ext cx="1100938" cy="1728216"/>
           </a:xfrm>
           <a:prstGeom prst="rect">
             <a:avLst/>
@@ -12119,8 +11899,8 @@
         </p:nvSpPr>
         <p:spPr>
           <a:xfrm>
-            <a:off x="2606040" y="2468880"/>
-            <a:ext cx="7772400" cy="457200"/>
+            <a:off x="2423160" y="2468880"/>
+            <a:ext cx="8823960" cy="457200"/>
           </a:xfrm>
           <a:prstGeom prst="rect">
             <a:avLst/>
@@ -12158,8 +11938,8 @@
         </p:nvSpPr>
         <p:spPr>
           <a:xfrm>
-            <a:off x="2606040" y="2926080"/>
-            <a:ext cx="7772400" cy="365760"/>
+            <a:off x="2423160" y="2926080"/>
+            <a:ext cx="8823960" cy="365760"/>
           </a:xfrm>
           <a:prstGeom prst="rect">
             <a:avLst/>
@@ -12197,8 +11977,8 @@
         </p:nvSpPr>
         <p:spPr>
           <a:xfrm>
-            <a:off x="2606040" y="3364992"/>
-            <a:ext cx="8138160" cy="1051560"/>
+            <a:off x="2423160" y="3364992"/>
+            <a:ext cx="8823960" cy="1051560"/>
           </a:xfrm>
           <a:prstGeom prst="rect">
             <a:avLst/>
@@ -12335,7 +12115,7 @@
                 <a:ea typeface="Cambria" pitchFamily="34" charset="-122"/>
                 <a:cs typeface="Cambria" pitchFamily="34" charset="-120"/>
               </a:rPr>
-              <a:t>TRL-7</a:t>
+              <a:t>R&amp;D Terverifikasi</a:t>
             </a:r>
             <a:endParaRPr lang="en-US" sz="1450" dirty="0"/>
           </a:p>
@@ -12377,7 +12157,7 @@
                 <a:ea typeface="Calibri" pitchFamily="34" charset="-122"/>
                 <a:cs typeface="Calibri" pitchFamily="34" charset="-120"/>
               </a:rPr>
-              <a:t>Level industri, teruji lapangan</a:t>
+              <a:t>Diuji langsung Lab IoT &amp; Fisika ITB</a:t>
             </a:r>
             <a:endParaRPr lang="en-US" sz="1050" dirty="0"/>
           </a:p>

</xml_diff>